<commit_message>
Enrich BOM deck Use case & Tech Talk boxes
Sync the marketing Bill of Materials deck with the source repo: adds a
concise "Concretely:" outcome line under Use case and a Tech Talk
summary paragraph (multi-model / multi-agent pattern, Foundry IQ
grounding, GenAIOps loop, MCP publishing to Microsoft 365 Copilot & Teams).

Co-authored-by: Copilot App <223556219+Copilot@users.noreply.github.com>
Copilot-Session: 2fc86db1-1f76-4b83-b234-329556a5f335
</commit_message>
<xml_diff>
--- a/03-Azure/01-04-AI/04_Agentic_Contract_Lifecycle_Management/docs/marketing/CLM-Microhack-BOM.pptx
+++ b/03-Azure/01-04-AI/04_Agentic_Contract_Lifecycle_Management/docs/marketing/CLM-Microhack-BOM.pptx
@@ -1193,7 +1193,7 @@
         <p:spPr>
           <a:xfrm>
             <a:off x="292608" y="1627632"/>
-            <a:ext cx="5650992" cy="1389888"/>
+            <a:ext cx="5650992" cy="1610868"/>
           </a:xfrm>
           <a:prstGeom prst="roundRect">
             <a:avLst>
@@ -1227,7 +1227,7 @@
         <p:spPr>
           <a:xfrm>
             <a:off x="438912" y="1700784"/>
-            <a:ext cx="5358384" cy="1243584"/>
+            <a:ext cx="5358384" cy="1543584"/>
           </a:xfrm>
           <a:prstGeom prst="rect">
             <a:avLst/>
@@ -1320,6 +1320,37 @@
                 <a:cs typeface="Segoe UI" pitchFamily="34" charset="-120"/>
               </a:rPr>
               <a:t>puts an orchestrator + grounded specialist agents on top: draft from approved templates, extract and risk-score clauses, answer cited questions, and proactively alert on renewals — with human sign-off and full tracing.</a:t>
+            </a:r>
+            <a:endParaRPr lang="en-US" sz="950" dirty="0"/>
+          </a:p>
+          <a:p>
+            <a:pPr algn="l" indent="0" marL="0">
+              <a:spcBef>
+                <a:spcPts val="600"/>
+              </a:spcBef>
+              <a:buNone/>
+            </a:pPr>
+            <a:r>
+              <a:rPr lang="en-US" sz="950" b="1" dirty="0">
+                <a:solidFill>
+                  <a:srgbClr val="1F6FB4"/>
+                </a:solidFill>
+                <a:latin typeface="Segoe UI" pitchFamily="34" charset="0"/>
+                <a:ea typeface="Segoe UI" pitchFamily="34" charset="-122"/>
+                <a:cs typeface="Segoe UI" pitchFamily="34" charset="-120"/>
+              </a:rPr>
+              <a:t xml:space="preserve">Concretely: </a:t>
+            </a:r>
+            <a:r>
+              <a:rPr lang="en-US" sz="950" dirty="0">
+                <a:solidFill>
+                  <a:srgbClr val="2B2B2B"/>
+                </a:solidFill>
+                <a:latin typeface="Segoe UI" pitchFamily="34" charset="0"/>
+                <a:ea typeface="Segoe UI" pitchFamily="34" charset="-122"/>
+                <a:cs typeface="Segoe UI" pitchFamily="34" charset="-120"/>
+              </a:rPr>
+              <a:t>cited template drafts, risk-scored clauses, and human-approved renewal alerts.</a:t>
             </a:r>
             <a:endParaRPr lang="en-US" sz="950" dirty="0"/>
           </a:p>
@@ -1341,7 +1372,7 @@
         </p:blipFill>
         <p:spPr>
           <a:xfrm>
-            <a:off x="292608" y="3108960"/>
+            <a:off x="292608" y="3328960"/>
             <a:ext cx="5650992" cy="329184"/>
           </a:xfrm>
           <a:prstGeom prst="rect">
@@ -1357,7 +1388,7 @@
         </p:nvSpPr>
         <p:spPr>
           <a:xfrm>
-            <a:off x="420624" y="3108960"/>
+            <a:off x="420624" y="3328960"/>
             <a:ext cx="3108046" cy="329184"/>
           </a:xfrm>
           <a:prstGeom prst="rect">
@@ -1396,7 +1427,7 @@
         </p:nvSpPr>
         <p:spPr>
           <a:xfrm>
-            <a:off x="292608" y="3456432"/>
+            <a:off x="292608" y="3676432"/>
             <a:ext cx="5650992" cy="329184"/>
           </a:xfrm>
           <a:prstGeom prst="roundRect">
@@ -1430,7 +1461,7 @@
         </p:nvSpPr>
         <p:spPr>
           <a:xfrm>
-            <a:off x="438912" y="3456432"/>
+            <a:off x="438912" y="3676432"/>
             <a:ext cx="5358384" cy="329184"/>
           </a:xfrm>
           <a:prstGeom prst="rect">
@@ -1469,7 +1500,7 @@
         </p:nvSpPr>
         <p:spPr>
           <a:xfrm>
-            <a:off x="292608" y="3822192"/>
+            <a:off x="292608" y="4042192"/>
             <a:ext cx="5650992" cy="2724912"/>
           </a:xfrm>
           <a:prstGeom prst="roundRect">
@@ -1503,7 +1534,7 @@
         </p:nvSpPr>
         <p:spPr>
           <a:xfrm>
-            <a:off x="438912" y="3950208"/>
+            <a:off x="438912" y="4170208"/>
             <a:ext cx="5358384" cy="310896"/>
           </a:xfrm>
           <a:prstGeom prst="roundRect">
@@ -1525,7 +1556,7 @@
         </p:nvSpPr>
         <p:spPr>
           <a:xfrm>
-            <a:off x="438912" y="3950208"/>
+            <a:off x="438912" y="4170208"/>
             <a:ext cx="5358384" cy="310896"/>
           </a:xfrm>
           <a:prstGeom prst="rect">
@@ -1578,7 +1609,7 @@
         </p:nvSpPr>
         <p:spPr>
           <a:xfrm>
-            <a:off x="1289304" y="4261104"/>
+            <a:off x="1289304" y="4481104"/>
             <a:ext cx="0" cy="201168"/>
           </a:xfrm>
           <a:prstGeom prst="line">
@@ -1601,7 +1632,7 @@
         </p:nvSpPr>
         <p:spPr>
           <a:xfrm>
-            <a:off x="438912" y="4462272"/>
+            <a:off x="438912" y="4682272"/>
             <a:ext cx="1700784" cy="859536"/>
           </a:xfrm>
           <a:prstGeom prst="roundRect">
@@ -1623,7 +1654,7 @@
         </p:nvSpPr>
         <p:spPr>
           <a:xfrm>
-            <a:off x="475488" y="4462272"/>
+            <a:off x="475488" y="4682272"/>
             <a:ext cx="1627632" cy="859536"/>
           </a:xfrm>
           <a:prstGeom prst="rect">
@@ -1696,7 +1727,7 @@
         </p:nvSpPr>
         <p:spPr>
           <a:xfrm>
-            <a:off x="3118104" y="4261104"/>
+            <a:off x="3118104" y="4481104"/>
             <a:ext cx="0" cy="201168"/>
           </a:xfrm>
           <a:prstGeom prst="line">
@@ -1719,7 +1750,7 @@
         </p:nvSpPr>
         <p:spPr>
           <a:xfrm>
-            <a:off x="2267712" y="4462272"/>
+            <a:off x="2267712" y="4682272"/>
             <a:ext cx="1700784" cy="859536"/>
           </a:xfrm>
           <a:prstGeom prst="roundRect">
@@ -1741,7 +1772,7 @@
         </p:nvSpPr>
         <p:spPr>
           <a:xfrm>
-            <a:off x="2304288" y="4462272"/>
+            <a:off x="2304288" y="4682272"/>
             <a:ext cx="1627632" cy="859536"/>
           </a:xfrm>
           <a:prstGeom prst="rect">
@@ -1814,7 +1845,7 @@
         </p:nvSpPr>
         <p:spPr>
           <a:xfrm>
-            <a:off x="4946904" y="4261104"/>
+            <a:off x="4946904" y="4481104"/>
             <a:ext cx="0" cy="201168"/>
           </a:xfrm>
           <a:prstGeom prst="line">
@@ -1837,7 +1868,7 @@
         </p:nvSpPr>
         <p:spPr>
           <a:xfrm>
-            <a:off x="4096512" y="4462272"/>
+            <a:off x="4096512" y="4682272"/>
             <a:ext cx="1700784" cy="859536"/>
           </a:xfrm>
           <a:prstGeom prst="roundRect">
@@ -1859,7 +1890,7 @@
         </p:nvSpPr>
         <p:spPr>
           <a:xfrm>
-            <a:off x="4133088" y="4462272"/>
+            <a:off x="4133088" y="4682272"/>
             <a:ext cx="1627632" cy="859536"/>
           </a:xfrm>
           <a:prstGeom prst="rect">
@@ -1932,7 +1963,7 @@
         </p:nvSpPr>
         <p:spPr>
           <a:xfrm>
-            <a:off x="438912" y="5449824"/>
+            <a:off x="438912" y="5669824"/>
             <a:ext cx="5358384" cy="292608"/>
           </a:xfrm>
           <a:prstGeom prst="roundRect">
@@ -1954,7 +1985,7 @@
         </p:nvSpPr>
         <p:spPr>
           <a:xfrm>
-            <a:off x="438912" y="5449824"/>
+            <a:off x="438912" y="5669824"/>
             <a:ext cx="5358384" cy="292608"/>
           </a:xfrm>
           <a:prstGeom prst="rect">
@@ -1993,7 +2024,7 @@
         </p:nvSpPr>
         <p:spPr>
           <a:xfrm>
-            <a:off x="438912" y="5779008"/>
+            <a:off x="438912" y="5999008"/>
             <a:ext cx="5358384" cy="292608"/>
           </a:xfrm>
           <a:prstGeom prst="roundRect">
@@ -2015,7 +2046,7 @@
         </p:nvSpPr>
         <p:spPr>
           <a:xfrm>
-            <a:off x="438912" y="5779008"/>
+            <a:off x="438912" y="5999008"/>
             <a:ext cx="5358384" cy="292608"/>
           </a:xfrm>
           <a:prstGeom prst="rect">
@@ -2054,7 +2085,7 @@
         </p:nvSpPr>
         <p:spPr>
           <a:xfrm>
-            <a:off x="438912" y="6108192"/>
+            <a:off x="438912" y="6328192"/>
             <a:ext cx="5358384" cy="274320"/>
           </a:xfrm>
           <a:prstGeom prst="rect">
@@ -3193,7 +3224,7 @@
         <p:spPr>
           <a:xfrm>
             <a:off x="6291072" y="3108960"/>
-            <a:ext cx="5449824" cy="859536"/>
+            <a:ext cx="5449824" cy="900000"/>
           </a:xfrm>
           <a:prstGeom prst="rect">
             <a:avLst/>
@@ -3218,6 +3249,26 @@
                 <a:cs typeface="Segoe UI" pitchFamily="34" charset="-120"/>
               </a:rPr>
               <a:t>Set the stage on Agentic AI + the Foundry platform, the CLM scenario and the IQ family (Foundry IQ / Web IQ). Includes a short demo of the assistant answering in Teams and firing a renewal alert. Two decks: FSI-Legal + industry-agnostic.</a:t>
+            </a:r>
+            <a:endParaRPr lang="en-US" sz="930" dirty="0"/>
+          </a:p>
+          <a:p>
+            <a:pPr algn="l" indent="0" marL="0">
+              <a:spcBef>
+                <a:spcPts val="500"/>
+              </a:spcBef>
+              <a:buNone/>
+            </a:pPr>
+            <a:r>
+              <a:rPr lang="en-US" sz="930" dirty="0">
+                <a:solidFill>
+                  <a:srgbClr val="2B2B2B"/>
+                </a:solidFill>
+                <a:latin typeface="Segoe UI" pitchFamily="34" charset="0"/>
+                <a:ea typeface="Segoe UI" pitchFamily="34" charset="-122"/>
+                <a:cs typeface="Segoe UI" pitchFamily="34" charset="-120"/>
+              </a:rPr>
+              <a:t>Covers the multi-model, multi-agent pattern (orchestrator + grounded specialists), grounding and citations with Foundry IQ, the GenAIOps loop — tracing, evaluation and safety — and MCP publishing to Microsoft 365 Copilot &amp; Teams. ~45–60 min: slides plus a live demo, no coding required to follow along.</a:t>
             </a:r>
             <a:endParaRPr lang="en-US" sz="930" dirty="0"/>
           </a:p>

</xml_diff>

<commit_message>
Rewrite Tech Talk box as clear three-beats overview
Sync the marketing deck with the source repo: the Tech Talk box is now a
scannable three-beats overview (Transformation & impact / Architecture &
services / Build -> Deploy -> Operate) with bold lead-ins, replacing the
two dense paragraphs.

Co-authored-by: Copilot App <223556219+Copilot@users.noreply.github.com>
Copilot-Session: 2fc86db1-1f76-4b83-b234-329556a5f335
</commit_message>
<xml_diff>
--- a/03-Azure/01-04-AI/04_Agentic_Contract_Lifecycle_Management/docs/marketing/CLM-Microhack-BOM.pptx
+++ b/03-Azure/01-04-AI/04_Agentic_Contract_Lifecycle_Management/docs/marketing/CLM-Microhack-BOM.pptx
@@ -3240,7 +3240,7 @@
               <a:buNone/>
             </a:pPr>
             <a:r>
-              <a:rPr lang="en-US" sz="930" dirty="0">
+              <a:rPr lang="en-US" sz="820" dirty="0">
                 <a:solidFill>
                   <a:srgbClr val="2B2B2B"/>
                 </a:solidFill>
@@ -3248,19 +3248,19 @@
                 <a:ea typeface="Segoe UI" pitchFamily="34" charset="-122"/>
                 <a:cs typeface="Segoe UI" pitchFamily="34" charset="-120"/>
               </a:rPr>
-              <a:t>Set the stage on Agentic AI + the Foundry platform, the CLM scenario and the IQ family (Foundry IQ / Web IQ). Includes a short demo of the assistant answering in Teams and firing a renewal alert. Two decks: FSI-Legal + industry-agnostic.</a:t>
-            </a:r>
-            <a:endParaRPr lang="en-US" sz="930" dirty="0"/>
+              <a:t>A short Tech Talk sets the stage on Agentic AI for contracts, in three beats:</a:t>
+            </a:r>
+            <a:endParaRPr lang="en-US" sz="820" dirty="0"/>
           </a:p>
           <a:p>
             <a:pPr algn="l" indent="0" marL="0">
               <a:spcBef>
-                <a:spcPts val="500"/>
+                <a:spcPts val="200"/>
               </a:spcBef>
               <a:buNone/>
             </a:pPr>
             <a:r>
-              <a:rPr lang="en-US" sz="930" dirty="0">
+              <a:rPr lang="en-US" sz="820" b="1" dirty="0">
                 <a:solidFill>
                   <a:srgbClr val="2B2B2B"/>
                 </a:solidFill>
@@ -3268,9 +3268,82 @@
                 <a:ea typeface="Segoe UI" pitchFamily="34" charset="-122"/>
                 <a:cs typeface="Segoe UI" pitchFamily="34" charset="-120"/>
               </a:rPr>
-              <a:t>Covers the multi-model, multi-agent pattern (orchestrator + grounded specialists), grounding and citations with Foundry IQ, the GenAIOps loop — tracing, evaluation and safety — and MCP publishing to Microsoft 365 Copilot &amp; Teams. ~45–60 min: slides plus a live demo, no coding required to follow along.</a:t>
-            </a:r>
-            <a:endParaRPr lang="en-US" sz="930" dirty="0"/>
+              <a:t>Transformation &amp; impact — </a:t>
+            </a:r>
+            <a:r>
+              <a:rPr lang="en-US" sz="820" dirty="0">
+                <a:solidFill>
+                  <a:srgbClr val="2B2B2B"/>
+                </a:solidFill>
+                <a:latin typeface="Segoe UI" pitchFamily="34" charset="0"/>
+                <a:ea typeface="Segoe UI" pitchFamily="34" charset="-122"/>
+                <a:cs typeface="Segoe UI" pitchFamily="34" charset="-120"/>
+              </a:rPr>
+              <a:t>moving from copilots to autonomous, reasoning agents — value in speed, risk and compliance, on Azure AI Foundry.</a:t>
+            </a:r>
+            <a:endParaRPr lang="en-US" sz="820" dirty="0"/>
+          </a:p>
+          <a:p>
+            <a:pPr algn="l" indent="0" marL="0">
+              <a:spcBef>
+                <a:spcPts val="200"/>
+              </a:spcBef>
+              <a:buNone/>
+            </a:pPr>
+            <a:r>
+              <a:rPr lang="en-US" sz="820" b="1" dirty="0">
+                <a:solidFill>
+                  <a:srgbClr val="2B2B2B"/>
+                </a:solidFill>
+                <a:latin typeface="Segoe UI" pitchFamily="34" charset="0"/>
+                <a:ea typeface="Segoe UI" pitchFamily="34" charset="-122"/>
+                <a:cs typeface="Segoe UI" pitchFamily="34" charset="-120"/>
+              </a:rPr>
+              <a:t>Architecture &amp; services — </a:t>
+            </a:r>
+            <a:r>
+              <a:rPr lang="en-US" sz="820" dirty="0">
+                <a:solidFill>
+                  <a:srgbClr val="2B2B2B"/>
+                </a:solidFill>
+                <a:latin typeface="Segoe UI" pitchFamily="34" charset="0"/>
+                <a:ea typeface="Segoe UI" pitchFamily="34" charset="-122"/>
+                <a:cs typeface="Segoe UI" pitchFamily="34" charset="-120"/>
+              </a:rPr>
+              <a:t>the multi-model, multi-agent pattern (orchestrator + grounded specialists) and the exact services used — Foundry IQ / Web IQ grounding and citations — familiar before you start.</a:t>
+            </a:r>
+            <a:endParaRPr lang="en-US" sz="820" dirty="0"/>
+          </a:p>
+          <a:p>
+            <a:pPr algn="l" indent="0" marL="0">
+              <a:spcBef>
+                <a:spcPts val="200"/>
+              </a:spcBef>
+              <a:buNone/>
+            </a:pPr>
+            <a:r>
+              <a:rPr lang="en-US" sz="820" b="1" dirty="0">
+                <a:solidFill>
+                  <a:srgbClr val="2B2B2B"/>
+                </a:solidFill>
+                <a:latin typeface="Segoe UI" pitchFamily="34" charset="0"/>
+                <a:ea typeface="Segoe UI" pitchFamily="34" charset="-122"/>
+                <a:cs typeface="Segoe UI" pitchFamily="34" charset="-120"/>
+              </a:rPr>
+              <a:t>Build → Deploy → Operate — </a:t>
+            </a:r>
+            <a:r>
+              <a:rPr lang="en-US" sz="820" dirty="0">
+                <a:solidFill>
+                  <a:srgbClr val="2B2B2B"/>
+                </a:solidFill>
+                <a:latin typeface="Segoe UI" pitchFamily="34" charset="0"/>
+                <a:ea typeface="Segoe UI" pitchFamily="34" charset="-122"/>
+                <a:cs typeface="Segoe UI" pitchFamily="34" charset="-120"/>
+              </a:rPr>
+              <a:t>build the agents, run the GenAIOps loop (tracing, evaluation, safety), and publish via MCP to Microsoft 365 Copilot &amp; Teams — capped with a live demo.</a:t>
+            </a:r>
+            <a:endParaRPr lang="en-US" sz="820" dirty="0"/>
           </a:p>
         </p:txBody>
       </p:sp>

</xml_diff>

<commit_message>
Add audience/extensibility note to Use case box
Sync the marketing deck: the Use case box now closes with a "Beyond FSI
& Legal" line noting the agentic pattern extends to any contract-heavy
function (procurement, sales, HR).

Co-authored-by: Copilot App <223556219+Copilot@users.noreply.github.com>
Copilot-Session: 2fc86db1-1f76-4b83-b234-329556a5f335
</commit_message>
<xml_diff>
--- a/03-Azure/01-04-AI/04_Agentic_Contract_Lifecycle_Management/docs/marketing/CLM-Microhack-BOM.pptx
+++ b/03-Azure/01-04-AI/04_Agentic_Contract_Lifecycle_Management/docs/marketing/CLM-Microhack-BOM.pptx
@@ -1240,13 +1240,10 @@
           <a:lstStyle/>
           <a:p>
             <a:pPr algn="l" indent="0" marL="0">
-              <a:spcAft>
-                <a:spcPts val="600"/>
-              </a:spcAft>
               <a:buNone/>
             </a:pPr>
             <a:r>
-              <a:rPr lang="en-US" sz="950" dirty="0">
+              <a:rPr lang="en-US" sz="880" dirty="0">
                 <a:solidFill>
                   <a:srgbClr val="2B2B2B"/>
                 </a:solidFill>
@@ -1256,82 +1253,37 @@
               </a:rPr>
               <a:t>Enterprises sign hundreds of contracts a month. Legal &amp; Procurement drown in intake, clause review and renewals — ~17-day turnaround and ~11% of auto-renewals missed.</a:t>
             </a:r>
-            <a:endParaRPr lang="en-US" sz="950" dirty="0"/>
-          </a:p>
-          <a:p>
-            <a:pPr algn="l" indent="0" marL="0">
-              <a:spcAft>
-                <a:spcPts val="600"/>
-              </a:spcAft>
-              <a:buNone/>
-            </a:pPr>
-            <a:r>
-              <a:rPr lang="en-US" sz="950" dirty="0">
-                <a:solidFill>
-                  <a:srgbClr val="2B2B2B"/>
-                </a:solidFill>
-                <a:latin typeface="Segoe UI" pitchFamily="34" charset="0"/>
-                <a:ea typeface="Segoe UI" pitchFamily="34" charset="-122"/>
-                <a:cs typeface="Segoe UI" pitchFamily="34" charset="-120"/>
-              </a:rPr>
-              <a:t>Traditional CLM is scattered across SharePoint, email and legacy systems; comparing a counterparty draft to the enterprise standard is slow and manual.</a:t>
-            </a:r>
-            <a:endParaRPr lang="en-US" sz="950" dirty="0"/>
-          </a:p>
-          <a:p>
-            <a:pPr algn="l" indent="0" marL="0">
-              <a:buNone/>
-            </a:pPr>
-            <a:r>
-              <a:rPr lang="en-US" sz="950" dirty="0">
-                <a:solidFill>
-                  <a:srgbClr val="2B2B2B"/>
-                </a:solidFill>
-                <a:latin typeface="Segoe UI" pitchFamily="34" charset="0"/>
-                <a:ea typeface="Segoe UI" pitchFamily="34" charset="-122"/>
-                <a:cs typeface="Segoe UI" pitchFamily="34" charset="-120"/>
-              </a:rPr>
-              <a:t/>
-            </a:r>
-            <a:pPr algn="l" indent="0" marL="0">
-              <a:buNone/>
-            </a:pPr>
-            <a:r>
-              <a:rPr lang="en-US" sz="950" b="1" dirty="0">
-                <a:solidFill>
-                  <a:srgbClr val="1F6FB4"/>
-                </a:solidFill>
-                <a:latin typeface="Segoe UI" pitchFamily="34" charset="0"/>
-                <a:ea typeface="Segoe UI" pitchFamily="34" charset="-122"/>
-                <a:cs typeface="Segoe UI" pitchFamily="34" charset="-120"/>
-              </a:rPr>
-              <a:t xml:space="preserve">Agentic CLM </a:t>
-            </a:r>
-            <a:pPr algn="l" indent="0" marL="0">
-              <a:buNone/>
-            </a:pPr>
-            <a:r>
-              <a:rPr lang="en-US" sz="950" dirty="0">
-                <a:solidFill>
-                  <a:srgbClr val="2B2B2B"/>
-                </a:solidFill>
-                <a:latin typeface="Segoe UI" pitchFamily="34" charset="0"/>
-                <a:ea typeface="Segoe UI" pitchFamily="34" charset="-122"/>
-                <a:cs typeface="Segoe UI" pitchFamily="34" charset="-120"/>
-              </a:rPr>
-              <a:t>puts an orchestrator + grounded specialist agents on top: draft from approved templates, extract and risk-score clauses, answer cited questions, and proactively alert on renewals — with human sign-off and full tracing.</a:t>
-            </a:r>
-            <a:endParaRPr lang="en-US" sz="950" dirty="0"/>
+            <a:endParaRPr lang="en-US" sz="880" dirty="0"/>
           </a:p>
           <a:p>
             <a:pPr algn="l" indent="0" marL="0">
               <a:spcBef>
-                <a:spcPts val="600"/>
+                <a:spcPts val="400"/>
               </a:spcBef>
               <a:buNone/>
             </a:pPr>
             <a:r>
-              <a:rPr lang="en-US" sz="950" b="1" dirty="0">
+              <a:rPr lang="en-US" sz="880" dirty="0">
+                <a:solidFill>
+                  <a:srgbClr val="2B2B2B"/>
+                </a:solidFill>
+                <a:latin typeface="Segoe UI" pitchFamily="34" charset="0"/>
+                <a:ea typeface="Segoe UI" pitchFamily="34" charset="-122"/>
+                <a:cs typeface="Segoe UI" pitchFamily="34" charset="-120"/>
+              </a:rPr>
+              <a:t>Traditional CLM is scattered across SharePoint, email and legacy systems; comparing a counterparty draft to the enterprise standard is slow and manual.</a:t>
+            </a:r>
+            <a:endParaRPr lang="en-US" sz="880" dirty="0"/>
+          </a:p>
+          <a:p>
+            <a:pPr algn="l" indent="0" marL="0">
+              <a:spcBef>
+                <a:spcPts val="400"/>
+              </a:spcBef>
+              <a:buNone/>
+            </a:pPr>
+            <a:r>
+              <a:rPr lang="en-US" sz="880" b="1" dirty="0">
                 <a:solidFill>
                   <a:srgbClr val="1F6FB4"/>
                 </a:solidFill>
@@ -1339,10 +1291,41 @@
                 <a:ea typeface="Segoe UI" pitchFamily="34" charset="-122"/>
                 <a:cs typeface="Segoe UI" pitchFamily="34" charset="-120"/>
               </a:rPr>
+              <a:t xml:space="preserve">Agentic CLM </a:t>
+            </a:r>
+            <a:r>
+              <a:rPr lang="en-US" sz="880" dirty="0">
+                <a:solidFill>
+                  <a:srgbClr val="2B2B2B"/>
+                </a:solidFill>
+                <a:latin typeface="Segoe UI" pitchFamily="34" charset="0"/>
+                <a:ea typeface="Segoe UI" pitchFamily="34" charset="-122"/>
+                <a:cs typeface="Segoe UI" pitchFamily="34" charset="-120"/>
+              </a:rPr>
+              <a:t>puts an orchestrator + grounded specialist agents on top: draft from approved templates, extract and risk-score clauses, answer cited questions, and proactively alert on renewals — with human sign-off and full tracing.</a:t>
+            </a:r>
+            <a:endParaRPr lang="en-US" sz="880" dirty="0"/>
+          </a:p>
+          <a:p>
+            <a:pPr algn="l" indent="0" marL="0">
+              <a:spcBef>
+                <a:spcPts val="400"/>
+              </a:spcBef>
+              <a:buNone/>
+            </a:pPr>
+            <a:r>
+              <a:rPr lang="en-US" sz="880" b="1" dirty="0">
+                <a:solidFill>
+                  <a:srgbClr val="1F6FB4"/>
+                </a:solidFill>
+                <a:latin typeface="Segoe UI" pitchFamily="34" charset="0"/>
+                <a:ea typeface="Segoe UI" pitchFamily="34" charset="-122"/>
+                <a:cs typeface="Segoe UI" pitchFamily="34" charset="-120"/>
+              </a:rPr>
               <a:t xml:space="preserve">Concretely: </a:t>
             </a:r>
             <a:r>
-              <a:rPr lang="en-US" sz="950" dirty="0">
+              <a:rPr lang="en-US" sz="880" dirty="0">
                 <a:solidFill>
                   <a:srgbClr val="2B2B2B"/>
                 </a:solidFill>
@@ -1352,7 +1335,38 @@
               </a:rPr>
               <a:t>cited template drafts, risk-scored clauses, and human-approved renewal alerts.</a:t>
             </a:r>
-            <a:endParaRPr lang="en-US" sz="950" dirty="0"/>
+            <a:endParaRPr lang="en-US" sz="880" dirty="0"/>
+          </a:p>
+          <a:p>
+            <a:pPr algn="l" indent="0" marL="0">
+              <a:spcBef>
+                <a:spcPts val="400"/>
+              </a:spcBef>
+              <a:buNone/>
+            </a:pPr>
+            <a:r>
+              <a:rPr lang="en-US" sz="880" b="1" dirty="0">
+                <a:solidFill>
+                  <a:srgbClr val="1F6FB4"/>
+                </a:solidFill>
+                <a:latin typeface="Segoe UI" pitchFamily="34" charset="0"/>
+                <a:ea typeface="Segoe UI" pitchFamily="34" charset="-122"/>
+                <a:cs typeface="Segoe UI" pitchFamily="34" charset="-120"/>
+              </a:rPr>
+              <a:t xml:space="preserve">Beyond FSI &amp; Legal: </a:t>
+            </a:r>
+            <a:r>
+              <a:rPr lang="en-US" sz="880" dirty="0">
+                <a:solidFill>
+                  <a:srgbClr val="2B2B2B"/>
+                </a:solidFill>
+                <a:latin typeface="Segoe UI" pitchFamily="34" charset="0"/>
+                <a:ea typeface="Segoe UI" pitchFamily="34" charset="-122"/>
+                <a:cs typeface="Segoe UI" pitchFamily="34" charset="-120"/>
+              </a:rPr>
+              <a:t>the agentic pattern extends to any contract-heavy function — procurement, sales, HR — so attendees leave with a template they can reuse in their own industry.</a:t>
+            </a:r>
+            <a:endParaRPr lang="en-US" sz="880" dirty="0"/>
           </a:p>
         </p:txBody>
       </p:sp>

</xml_diff>

<commit_message>
Reframe Use case as cross-industry with real impact metrics
Sync the marketing deck: the CLM use case is now positioned as
cross-industry (not FSI/Legal), with real impact figures and a
Cross-industry deck link.

Co-authored-by: Copilot App <223556219+Copilot@users.noreply.github.com>
Copilot-Session: 2fc86db1-1f76-4b83-b234-329556a5f335
</commit_message>
<xml_diff>
--- a/03-Azure/01-04-AI/04_Agentic_Contract_Lifecycle_Management/docs/marketing/CLM-Microhack-BOM.pptx
+++ b/03-Azure/01-04-AI/04_Agentic_Contract_Lifecycle_Management/docs/marketing/CLM-Microhack-BOM.pptx
@@ -1243,7 +1243,7 @@
               <a:buNone/>
             </a:pPr>
             <a:r>
-              <a:rPr lang="en-US" sz="880" dirty="0">
+              <a:rPr lang="en-US" sz="850" dirty="0">
                 <a:solidFill>
                   <a:srgbClr val="2B2B2B"/>
                 </a:solidFill>
@@ -1251,9 +1251,9 @@
                 <a:ea typeface="Segoe UI" pitchFamily="34" charset="-122"/>
                 <a:cs typeface="Segoe UI" pitchFamily="34" charset="-120"/>
               </a:rPr>
-              <a:t>Enterprises sign hundreds of contracts a month. Legal &amp; Procurement drown in intake, clause review and renewals — ~17-day turnaround and ~11% of auto-renewals missed.</a:t>
-            </a:r>
-            <a:endParaRPr lang="en-US" sz="880" dirty="0"/>
+              <a:t>Every organization runs on contracts. Drafts arrive in mixed formats, clause libraries go unused, reviews stall in inboxes, and obligations slip after signature.</a:t>
+            </a:r>
+            <a:endParaRPr lang="en-US" sz="850" dirty="0"/>
           </a:p>
           <a:p>
             <a:pPr algn="l" indent="0" marL="0">
@@ -1263,7 +1263,7 @@
               <a:buNone/>
             </a:pPr>
             <a:r>
-              <a:rPr lang="en-US" sz="880" dirty="0">
+              <a:rPr lang="en-US" sz="850" dirty="0">
                 <a:solidFill>
                   <a:srgbClr val="2B2B2B"/>
                 </a:solidFill>
@@ -1271,9 +1271,9 @@
                 <a:ea typeface="Segoe UI" pitchFamily="34" charset="-122"/>
                 <a:cs typeface="Segoe UI" pitchFamily="34" charset="-120"/>
               </a:rPr>
-              <a:t>Traditional CLM is scattered across SharePoint, email and legacy systems; comparing a counterparty draft to the enterprise standard is slow and manual.</a:t>
-            </a:r>
-            <a:endParaRPr lang="en-US" sz="880" dirty="0"/>
+              <a:t>Comparing a third-party draft to the enterprise standard is slow and manual, so deviations and missed renewals go unnoticed until they cost money.</a:t>
+            </a:r>
+            <a:endParaRPr lang="en-US" sz="850" dirty="0"/>
           </a:p>
           <a:p>
             <a:pPr algn="l" indent="0" marL="0">
@@ -1283,7 +1283,7 @@
               <a:buNone/>
             </a:pPr>
             <a:r>
-              <a:rPr lang="en-US" sz="880" b="1" dirty="0">
+              <a:rPr lang="en-US" sz="850" b="1" dirty="0">
                 <a:solidFill>
                   <a:srgbClr val="1F6FB4"/>
                 </a:solidFill>
@@ -1294,7 +1294,7 @@
               <a:t xml:space="preserve">Agentic CLM </a:t>
             </a:r>
             <a:r>
-              <a:rPr lang="en-US" sz="880" dirty="0">
+              <a:rPr lang="en-US" sz="850" dirty="0">
                 <a:solidFill>
                   <a:srgbClr val="2B2B2B"/>
                 </a:solidFill>
@@ -1302,9 +1302,9 @@
                 <a:ea typeface="Segoe UI" pitchFamily="34" charset="-122"/>
                 <a:cs typeface="Segoe UI" pitchFamily="34" charset="-120"/>
               </a:rPr>
-              <a:t>puts an orchestrator + grounded specialist agents on top: draft from approved templates, extract and risk-score clauses, answer cited questions, and proactively alert on renewals — with human sign-off and full tracing.</a:t>
-            </a:r>
-            <a:endParaRPr lang="en-US" sz="880" dirty="0"/>
+              <a:t>puts an orchestrator + grounded specialist agents on top: draft from approved templates, extract and risk-score clauses, route reviews, capture e-signatures, and track obligations — with human sign-off and full tracing.</a:t>
+            </a:r>
+            <a:endParaRPr lang="en-US" sz="850" dirty="0"/>
           </a:p>
           <a:p>
             <a:pPr algn="l" indent="0" marL="0">
@@ -1314,7 +1314,7 @@
               <a:buNone/>
             </a:pPr>
             <a:r>
-              <a:rPr lang="en-US" sz="880" b="1" dirty="0">
+              <a:rPr lang="en-US" sz="850" b="1" dirty="0">
                 <a:solidFill>
                   <a:srgbClr val="1F6FB4"/>
                 </a:solidFill>
@@ -1322,10 +1322,10 @@
                 <a:ea typeface="Segoe UI" pitchFamily="34" charset="-122"/>
                 <a:cs typeface="Segoe UI" pitchFamily="34" charset="-120"/>
               </a:rPr>
-              <a:t xml:space="preserve">Concretely: </a:t>
-            </a:r>
-            <a:r>
-              <a:rPr lang="en-US" sz="880" dirty="0">
+              <a:t xml:space="preserve">Impact: </a:t>
+            </a:r>
+            <a:r>
+              <a:rPr lang="en-US" sz="850" dirty="0">
                 <a:solidFill>
                   <a:srgbClr val="2B2B2B"/>
                 </a:solidFill>
@@ -1333,9 +1333,9 @@
                 <a:ea typeface="Segoe UI" pitchFamily="34" charset="-122"/>
                 <a:cs typeface="Segoe UI" pitchFamily="34" charset="-120"/>
               </a:rPr>
-              <a:t>cited template drafts, risk-scored clauses, and human-approved renewal alerts.</a:t>
-            </a:r>
-            <a:endParaRPr lang="en-US" sz="880" dirty="0"/>
+              <a:t>~30–50% faster request-to-signature, ~15–30% less outside counsel &amp; rework, and ~2–5% less revenue leakage from missed renewals.</a:t>
+            </a:r>
+            <a:endParaRPr lang="en-US" sz="850" dirty="0"/>
           </a:p>
           <a:p>
             <a:pPr algn="l" indent="0" marL="0">
@@ -1345,7 +1345,7 @@
               <a:buNone/>
             </a:pPr>
             <a:r>
-              <a:rPr lang="en-US" sz="880" b="1" dirty="0">
+              <a:rPr lang="en-US" sz="850" b="1" dirty="0">
                 <a:solidFill>
                   <a:srgbClr val="1F6FB4"/>
                 </a:solidFill>
@@ -1353,10 +1353,10 @@
                 <a:ea typeface="Segoe UI" pitchFamily="34" charset="-122"/>
                 <a:cs typeface="Segoe UI" pitchFamily="34" charset="-120"/>
               </a:rPr>
-              <a:t xml:space="preserve">Beyond FSI &amp; Legal: </a:t>
-            </a:r>
-            <a:r>
-              <a:rPr lang="en-US" sz="880" dirty="0">
+              <a:t xml:space="preserve">Cross-industry: </a:t>
+            </a:r>
+            <a:r>
+              <a:rPr lang="en-US" sz="850" dirty="0">
                 <a:solidFill>
                   <a:srgbClr val="2B2B2B"/>
                 </a:solidFill>
@@ -1364,9 +1364,9 @@
                 <a:ea typeface="Segoe UI" pitchFamily="34" charset="-122"/>
                 <a:cs typeface="Segoe UI" pitchFamily="34" charset="-120"/>
               </a:rPr>
-              <a:t>the agentic pattern extends to any contract-heavy function — procurement, sales, HR — so attendees leave with a template they can reuse in their own industry.</a:t>
-            </a:r>
-            <a:endParaRPr lang="en-US" sz="880" dirty="0"/>
+              <a:t>every sector runs on contracts, so the same pattern serves legal, procurement and sales in any business — attendees leave with a reusable template.</a:t>
+            </a:r>
+            <a:endParaRPr lang="en-US" sz="850" dirty="0"/>
           </a:p>
         </p:txBody>
       </p:sp>
@@ -3147,39 +3147,8 @@
                 <a:ea typeface="Segoe UI" pitchFamily="34" charset="-122"/>
                 <a:cs typeface="Segoe UI" pitchFamily="34" charset="-120"/>
               </a:rPr>
-              <a:t xml:space="preserve">Agnostic </a:t>
-            </a:r>
-            <a:pPr algn="r" indent="0" marL="0">
-              <a:buNone/>
-            </a:pPr>
-            <a:r>
-              <a:rPr lang="en-US" sz="850" b="1" dirty="0">
-                <a:solidFill>
-                  <a:srgbClr val="F4C430"/>
-                </a:solidFill>
-                <a:latin typeface="Segoe UI" pitchFamily="34" charset="0"/>
-                <a:ea typeface="Segoe UI" pitchFamily="34" charset="-122"/>
-                <a:cs typeface="Segoe UI" pitchFamily="34" charset="-120"/>
-              </a:rPr>
-              <a:t>HERE</a:t>
-            </a:r>
-            <a:pPr algn="r" indent="0" marL="0">
-              <a:buNone/>
-            </a:pPr>
-            <a:r>
-              <a:rPr lang="en-US" sz="850" dirty="0">
-                <a:solidFill>
-                  <a:srgbClr val="FFFFFF"/>
-                </a:solidFill>
-                <a:latin typeface="Segoe UI" pitchFamily="34" charset="0"/>
-                <a:ea typeface="Segoe UI" pitchFamily="34" charset="-122"/>
-                <a:cs typeface="Segoe UI" pitchFamily="34" charset="-120"/>
-              </a:rPr>
-              <a:t xml:space="preserve"> / FSI-Legal </a:t>
-            </a:r>
-            <a:pPr algn="r" indent="0" marL="0">
-              <a:buNone/>
-            </a:pPr>
+              <a:t xml:space="preserve">Cross-industry deck </a:t>
+            </a:r>
             <a:r>
               <a:rPr lang="en-US" sz="850" b="1" dirty="0">
                 <a:solidFill>

</xml_diff>